<commit_message>
Refresh ESG hackathon final submission package
</commit_message>
<xml_diff>
--- a/09_submission/02_presentation/초ROK_수페스타_발표자료.pptx
+++ b/09_submission/02_presentation/초ROK_수페스타_발표자료.pptx
@@ -2003,8 +2003,8 @@
         </p:nvSpPr>
         <p:spPr>
           <a:xfrm>
-            <a:off x="7543800" y="-1143000"/>
-            <a:ext cx="5394960" cy="5394960"/>
+            <a:off x="7918704" y="164592"/>
+            <a:ext cx="4041648" cy="4041648"/>
           </a:xfrm>
           <a:prstGeom prst="ellipse">
             <a:avLst/>
@@ -2677,7 +2677,7 @@
                 <a:ea typeface="Apple SD Gothic Neo" pitchFamily="34" charset="-122"/>
                 <a:cs typeface="Apple SD Gothic Neo" pitchFamily="34" charset="-120"/>
               </a:rPr>
-              <a:t>23</a:t>
+              <a:t>35</a:t>
             </a:r>
             <a:endParaRPr lang="en-US" sz="1250" dirty="0"/>
           </a:p>
@@ -2718,7 +2718,7 @@
                 <a:ea typeface="Apple SD Gothic Neo" pitchFamily="34" charset="-122"/>
                 <a:cs typeface="Apple SD Gothic Neo" pitchFamily="34" charset="-120"/>
               </a:rPr>
-              <a:t>단위·통합 테스트</a:t>
+              <a:t>자동 테스트</a:t>
             </a:r>
             <a:endParaRPr lang="en-US" sz="1020" dirty="0"/>
           </a:p>
@@ -2828,7 +2828,7 @@
                 <a:ea typeface="Apple SD Gothic Neo" pitchFamily="34" charset="-122"/>
                 <a:cs typeface="Apple SD Gothic Neo" pitchFamily="34" charset="-120"/>
               </a:rPr>
-              <a:t>60</a:t>
+              <a:t>63</a:t>
             </a:r>
             <a:endParaRPr lang="en-US" sz="1250" dirty="0"/>
           </a:p>
@@ -2979,7 +2979,7 @@
                 <a:ea typeface="Apple SD Gothic Neo" pitchFamily="34" charset="-122"/>
                 <a:cs typeface="Apple SD Gothic Neo" pitchFamily="34" charset="-120"/>
               </a:rPr>
-              <a:t>8</a:t>
+              <a:t>10</a:t>
             </a:r>
             <a:endParaRPr lang="en-US" sz="1250" dirty="0"/>
           </a:p>
@@ -3738,24 +3738,26 @@
         </p:nvSpPr>
         <p:spPr>
           <a:xfrm>
-            <a:off x="8229600" y="5650992"/>
-            <a:ext cx="2377440" cy="256032"/>
-          </a:xfrm>
-          <a:prstGeom prst="rect">
-            <a:avLst/>
-          </a:prstGeom>
-          <a:noFill/>
-          <a:ln/>
-        </p:spPr>
-        <p:txBody>
-          <a:bodyPr wrap="square" lIns="0" tIns="0" rIns="0" bIns="0" rtlCol="0" anchor="ctr"/>
+            <a:off x="7772400" y="5522976"/>
+            <a:ext cx="3337560" cy="530352"/>
+          </a:xfrm>
+          <a:prstGeom prst="rect">
+            <a:avLst/>
+          </a:prstGeom>
+          <a:noFill/>
+          <a:ln/>
+        </p:spPr>
+        <p:txBody>
+          <a:bodyPr wrap="square" lIns="0" tIns="0" rIns="0" bIns="0" rtlCol="0" anchor="ctr">
+            <a:normAutofit/>
+          </a:bodyPr>
           <a:lstStyle/>
           <a:p>
             <a:pPr algn="ctr" indent="0" marL="0">
               <a:buNone/>
             </a:pPr>
             <a:r>
-              <a:rPr lang="en-US" sz="1100" dirty="0">
+              <a:rPr lang="en-US" sz="950" dirty="0">
                 <a:solidFill>
                   <a:srgbClr val="C8DAD4"/>
                 </a:solidFill>
@@ -3765,7 +3767,24 @@
               </a:rPr>
               <a:t>팀 초 ROK · 박상훈</a:t>
             </a:r>
-            <a:endParaRPr lang="en-US" sz="1100" dirty="0"/>
+            <a:endParaRPr lang="en-US" sz="950" dirty="0"/>
+          </a:p>
+          <a:p>
+            <a:pPr algn="ctr" indent="0" marL="0">
+              <a:buNone/>
+            </a:pPr>
+            <a:r>
+              <a:rPr lang="en-US" sz="950" dirty="0">
+                <a:solidFill>
+                  <a:srgbClr val="C8DAD4"/>
+                </a:solidFill>
+                <a:latin typeface="Apple SD Gothic Neo" pitchFamily="34" charset="0"/>
+                <a:ea typeface="Apple SD Gothic Neo" pitchFamily="34" charset="-122"/>
+                <a:cs typeface="Apple SD Gothic Neo" pitchFamily="34" charset="-120"/>
+              </a:rPr>
+              <a:t>github.com/pak3430/supestar-esg-ai</a:t>
+            </a:r>
+            <a:endParaRPr lang="en-US" sz="950" dirty="0"/>
           </a:p>
         </p:txBody>
       </p:sp>

</xml_diff>

<commit_message>
Document verified Qwen Cloud deployment
</commit_message>
<xml_diff>
--- a/09_submission/02_presentation/초ROK_수페스타_발표자료.pptx
+++ b/09_submission/02_presentation/초ROK_수페스타_발표자료.pptx
@@ -2208,7 +2208,7 @@
                 <a:ea typeface="Apple SD Gothic Neo" pitchFamily="34" charset="-122"/>
                 <a:cs typeface="Apple SD Gothic Neo" pitchFamily="34" charset="-120"/>
               </a:rPr>
-              <a:t>로컬 AI가 검증 결과만 자연어로 설명합니다.</a:t>
+              <a:t>선택적 로컬·서버 AI가 검증 결과만 자연어로 설명합니다.</a:t>
             </a:r>
             <a:endParaRPr lang="en-US" sz="1400" dirty="0"/>
           </a:p>
@@ -2677,7 +2677,7 @@
                 <a:ea typeface="Apple SD Gothic Neo" pitchFamily="34" charset="-122"/>
                 <a:cs typeface="Apple SD Gothic Neo" pitchFamily="34" charset="-120"/>
               </a:rPr>
-              <a:t>35</a:t>
+              <a:t>36</a:t>
             </a:r>
             <a:endParaRPr lang="en-US" sz="1250" dirty="0"/>
           </a:p>
@@ -2828,7 +2828,7 @@
                 <a:ea typeface="Apple SD Gothic Neo" pitchFamily="34" charset="-122"/>
                 <a:cs typeface="Apple SD Gothic Neo" pitchFamily="34" charset="-120"/>
               </a:rPr>
-              <a:t>63</a:t>
+              <a:t>64</a:t>
             </a:r>
             <a:endParaRPr lang="en-US" sz="1250" dirty="0"/>
           </a:p>
@@ -2979,7 +2979,7 @@
                 <a:ea typeface="Apple SD Gothic Neo" pitchFamily="34" charset="-122"/>
                 <a:cs typeface="Apple SD Gothic Neo" pitchFamily="34" charset="-120"/>
               </a:rPr>
-              <a:t>10</a:t>
+              <a:t>10 + 5</a:t>
             </a:r>
             <a:endParaRPr lang="en-US" sz="1250" dirty="0"/>
           </a:p>
@@ -3020,7 +3020,7 @@
                 <a:ea typeface="Apple SD Gothic Neo" pitchFamily="34" charset="-122"/>
                 <a:cs typeface="Apple SD Gothic Neo" pitchFamily="34" charset="-120"/>
               </a:rPr>
-              <a:t>로컬 AI 근거 답변</a:t>
+              <a:t>로컬 AI 10 · 공개 Qwen 5</a:t>
             </a:r>
             <a:endParaRPr lang="en-US" sz="1020" dirty="0"/>
           </a:p>
@@ -6623,7 +6623,7 @@
                 <a:ea typeface="Apple SD Gothic Neo" pitchFamily="34" charset="-122"/>
                 <a:cs typeface="Apple SD Gothic Neo" pitchFamily="34" charset="-120"/>
               </a:rPr>
-              <a:t>판정은 Skill이 만들고, 로컬 AI는 검증 결과만 설명합니다</a:t>
+              <a:t>판정은 Skill이 만들고, AI는 검증 결과만 설명합니다</a:t>
             </a:r>
             <a:endParaRPr lang="en-US" sz="2500" dirty="0"/>
           </a:p>
@@ -7517,7 +7517,7 @@
                 <a:ea typeface="Apple SD Gothic Neo" pitchFamily="34" charset="-122"/>
                 <a:cs typeface="Apple SD Gothic Neo" pitchFamily="34" charset="-120"/>
               </a:rPr>
-              <a:t>5 · Local AI</a:t>
+              <a:t>5 · Local/Server AI</a:t>
             </a:r>
             <a:endParaRPr lang="en-US" sz="1250" dirty="0"/>
           </a:p>
@@ -10757,7 +10757,7 @@
                 <a:ea typeface="Apple SD Gothic Neo" pitchFamily="34" charset="-122"/>
                 <a:cs typeface="Apple SD Gothic Neo" pitchFamily="34" charset="-120"/>
               </a:rPr>
-              <a:t>REVIEW/STOP에서는 로컬 AI 자유 생성 차단</a:t>
+              <a:t>REVIEW/STOP에서는 생성형 AI 자유 생성 차단</a:t>
             </a:r>
             <a:endParaRPr lang="en-US" sz="900" dirty="0"/>
           </a:p>

</xml_diff>